<commit_message>
Office Export: neutral by default (Calibri, blue-gray, no label or byline), optional label, opt-in family art, Excel keeps its original look
Co-Authored-By: Claude Sonnet 5.5 <noreply@anthropic.com>
Claude-Session: https://claude.ai/code/session_01Qs56CyPwtQAdyeiDNLqDfK
</commit_message>
<xml_diff>
--- a/tools/samples/Sample-Deck.pptx
+++ b/tools/samples/Sample-Deck.pptx
@@ -3512,7 +3512,7 @@
     <p:bg>
       <p:bgPr>
         <a:solidFill>
-          <a:srgbClr val="17384F"/>
+          <a:srgbClr val="1E3141"/>
         </a:solidFill>
         <a:effectLst/>
       </p:bgPr>
@@ -3526,74 +3526,20 @@
       <p:grpSpPr/>
       <p:sp>
         <p:nvSpPr>
-          <p:cNvPr id="2" name="Freeform 1"/>
+          <p:cNvPr id="2" name="Rectangle 1"/>
           <p:cNvSpPr/>
           <p:nvPr/>
         </p:nvSpPr>
         <p:spPr>
           <a:xfrm>
-            <a:off x="0" y="3977639"/>
-            <a:ext cx="12191695" cy="2880361"/>
-          </a:xfrm>
-          <a:custGeom>
+            <a:off x="822960" y="1554480"/>
+            <a:ext cx="822960" cy="82296"/>
+          </a:xfrm>
+          <a:prstGeom prst="rect">
             <a:avLst/>
-            <a:gdLst/>
-            <a:ahLst/>
-            <a:cxnLst/>
-            <a:rect l="l" t="t" r="r" b="b"/>
-            <a:pathLst>
-              <a:path w="12191695" h="2880361">
-                <a:moveTo>
-                  <a:pt x="0" y="2880361"/>
-                </a:moveTo>
-                <a:lnTo>
-                  <a:pt x="0" y="1371601"/>
-                </a:lnTo>
-                <a:lnTo>
-                  <a:pt x="853418" y="822961"/>
-                </a:lnTo>
-                <a:lnTo>
-                  <a:pt x="1463003" y="1097281"/>
-                </a:lnTo>
-                <a:lnTo>
-                  <a:pt x="2438339" y="137161"/>
-                </a:lnTo>
-                <a:lnTo>
-                  <a:pt x="3291757" y="685801"/>
-                </a:lnTo>
-                <a:lnTo>
-                  <a:pt x="4145176" y="411481"/>
-                </a:lnTo>
-                <a:lnTo>
-                  <a:pt x="5364345" y="1234441"/>
-                </a:lnTo>
-                <a:lnTo>
-                  <a:pt x="6583515" y="548641"/>
-                </a:lnTo>
-                <a:lnTo>
-                  <a:pt x="7558850" y="960121"/>
-                </a:lnTo>
-                <a:lnTo>
-                  <a:pt x="8534186" y="0"/>
-                </a:lnTo>
-                <a:lnTo>
-                  <a:pt x="9509522" y="685801"/>
-                </a:lnTo>
-                <a:lnTo>
-                  <a:pt x="10484857" y="274321"/>
-                </a:lnTo>
-                <a:lnTo>
-                  <a:pt x="12191695" y="1097281"/>
-                </a:lnTo>
-                <a:lnTo>
-                  <a:pt x="12191695" y="2880361"/>
-                </a:lnTo>
-                <a:close/>
-              </a:path>
-            </a:pathLst>
-          </a:custGeom>
+          </a:prstGeom>
           <a:solidFill>
-            <a:srgbClr val="245B7E"/>
+            <a:srgbClr val="7C9CBA"/>
           </a:solidFill>
           <a:ln>
             <a:noFill/>
@@ -3624,320 +3570,14 @@
       </p:sp>
       <p:sp>
         <p:nvSpPr>
-          <p:cNvPr id="3" name="Freeform 2"/>
-          <p:cNvSpPr/>
-          <p:nvPr/>
-        </p:nvSpPr>
-        <p:spPr>
-          <a:xfrm>
-            <a:off x="0" y="5623560"/>
-            <a:ext cx="12191695" cy="1234440"/>
-          </a:xfrm>
-          <a:custGeom>
-            <a:avLst/>
-            <a:gdLst/>
-            <a:ahLst/>
-            <a:cxnLst/>
-            <a:rect l="l" t="t" r="r" b="b"/>
-            <a:pathLst>
-              <a:path w="12191695" h="1234440">
-                <a:moveTo>
-                  <a:pt x="0" y="1234440"/>
-                </a:moveTo>
-                <a:lnTo>
-                  <a:pt x="0" y="548640"/>
-                </a:lnTo>
-                <a:lnTo>
-                  <a:pt x="1219169" y="205740"/>
-                </a:lnTo>
-                <a:lnTo>
-                  <a:pt x="2438339" y="411480"/>
-                </a:lnTo>
-                <a:lnTo>
-                  <a:pt x="4023259" y="0"/>
-                </a:lnTo>
-                <a:lnTo>
-                  <a:pt x="5608179" y="480060"/>
-                </a:lnTo>
-                <a:lnTo>
-                  <a:pt x="7315017" y="137160"/>
-                </a:lnTo>
-                <a:lnTo>
-                  <a:pt x="9143771" y="548640"/>
-                </a:lnTo>
-                <a:lnTo>
-                  <a:pt x="10728691" y="205740"/>
-                </a:lnTo>
-                <a:lnTo>
-                  <a:pt x="12191695" y="480060"/>
-                </a:lnTo>
-                <a:lnTo>
-                  <a:pt x="12191695" y="1234440"/>
-                </a:lnTo>
-                <a:close/>
-              </a:path>
-            </a:pathLst>
-          </a:custGeom>
-          <a:solidFill>
-            <a:srgbClr val="587F5A"/>
-          </a:solidFill>
-          <a:ln>
-            <a:noFill/>
-          </a:ln>
-          <a:effectLst/>
-        </p:spPr>
-        <p:style>
-          <a:lnRef idx="1">
-            <a:schemeClr val="accent1"/>
-          </a:lnRef>
-          <a:fillRef idx="3">
-            <a:schemeClr val="accent1"/>
-          </a:fillRef>
-          <a:effectRef idx="2">
-            <a:schemeClr val="accent1"/>
-          </a:effectRef>
-          <a:fontRef idx="minor">
-            <a:schemeClr val="lt1"/>
-          </a:fontRef>
-        </p:style>
-        <p:txBody>
-          <a:bodyPr rtlCol="0" anchor="ctr"/>
-          <a:lstStyle/>
-          <a:p>
-            <a:pPr algn="ctr"/>
-          </a:p>
-        </p:txBody>
-      </p:sp>
-      <p:sp>
-        <p:nvSpPr>
-          <p:cNvPr id="4" name="Rectangle 3"/>
-          <p:cNvSpPr/>
-          <p:nvPr/>
-        </p:nvSpPr>
-        <p:spPr>
-          <a:xfrm>
-            <a:off x="8525042" y="3557015"/>
-            <a:ext cx="18288" cy="420624"/>
-          </a:xfrm>
-          <a:prstGeom prst="rect">
-            <a:avLst/>
-          </a:prstGeom>
-          <a:solidFill>
-            <a:srgbClr val="E9EEF3"/>
-          </a:solidFill>
-          <a:ln>
-            <a:noFill/>
-          </a:ln>
-          <a:effectLst/>
-        </p:spPr>
-        <p:style>
-          <a:lnRef idx="1">
-            <a:schemeClr val="accent1"/>
-          </a:lnRef>
-          <a:fillRef idx="3">
-            <a:schemeClr val="accent1"/>
-          </a:fillRef>
-          <a:effectRef idx="2">
-            <a:schemeClr val="accent1"/>
-          </a:effectRef>
-          <a:fontRef idx="minor">
-            <a:schemeClr val="lt1"/>
-          </a:fontRef>
-        </p:style>
-        <p:txBody>
-          <a:bodyPr rtlCol="0" anchor="ctr"/>
-          <a:lstStyle/>
-          <a:p>
-            <a:pPr algn="ctr"/>
-          </a:p>
-        </p:txBody>
-      </p:sp>
-      <p:sp>
-        <p:nvSpPr>
-          <p:cNvPr id="5" name="Rectangle 4"/>
-          <p:cNvSpPr/>
-          <p:nvPr/>
-        </p:nvSpPr>
-        <p:spPr>
-          <a:xfrm>
-            <a:off x="8552474" y="3557015"/>
-            <a:ext cx="237744" cy="237744"/>
-          </a:xfrm>
-          <a:prstGeom prst="rect">
-            <a:avLst/>
-          </a:prstGeom>
-          <a:solidFill>
-            <a:srgbClr val="D52B1E"/>
-          </a:solidFill>
-          <a:ln>
-            <a:noFill/>
-          </a:ln>
-          <a:effectLst/>
-        </p:spPr>
-        <p:style>
-          <a:lnRef idx="1">
-            <a:schemeClr val="accent1"/>
-          </a:lnRef>
-          <a:fillRef idx="3">
-            <a:schemeClr val="accent1"/>
-          </a:fillRef>
-          <a:effectRef idx="2">
-            <a:schemeClr val="accent1"/>
-          </a:effectRef>
-          <a:fontRef idx="minor">
-            <a:schemeClr val="lt1"/>
-          </a:fontRef>
-        </p:style>
-        <p:txBody>
-          <a:bodyPr rtlCol="0" anchor="ctr"/>
-          <a:lstStyle/>
-          <a:p>
-            <a:pPr algn="ctr"/>
-          </a:p>
-        </p:txBody>
-      </p:sp>
-      <p:sp>
-        <p:nvSpPr>
-          <p:cNvPr id="6" name="Rectangle 5"/>
-          <p:cNvSpPr/>
-          <p:nvPr/>
-        </p:nvSpPr>
-        <p:spPr>
-          <a:xfrm>
-            <a:off x="8639342" y="3602735"/>
-            <a:ext cx="27432" cy="146304"/>
-          </a:xfrm>
-          <a:prstGeom prst="rect">
-            <a:avLst/>
-          </a:prstGeom>
-          <a:solidFill>
-            <a:srgbClr val="FFFFFF"/>
-          </a:solidFill>
-          <a:ln>
-            <a:noFill/>
-          </a:ln>
-          <a:effectLst/>
-        </p:spPr>
-        <p:style>
-          <a:lnRef idx="1">
-            <a:schemeClr val="accent1"/>
-          </a:lnRef>
-          <a:fillRef idx="3">
-            <a:schemeClr val="accent1"/>
-          </a:fillRef>
-          <a:effectRef idx="2">
-            <a:schemeClr val="accent1"/>
-          </a:effectRef>
-          <a:fontRef idx="minor">
-            <a:schemeClr val="lt1"/>
-          </a:fontRef>
-        </p:style>
-        <p:txBody>
-          <a:bodyPr rtlCol="0" anchor="ctr"/>
-          <a:lstStyle/>
-          <a:p>
-            <a:pPr algn="ctr"/>
-          </a:p>
-        </p:txBody>
-      </p:sp>
-      <p:sp>
-        <p:nvSpPr>
-          <p:cNvPr id="7" name="Rectangle 6"/>
-          <p:cNvSpPr/>
-          <p:nvPr/>
-        </p:nvSpPr>
-        <p:spPr>
-          <a:xfrm>
-            <a:off x="8602766" y="3662171"/>
-            <a:ext cx="109728" cy="27432"/>
-          </a:xfrm>
-          <a:prstGeom prst="rect">
-            <a:avLst/>
-          </a:prstGeom>
-          <a:solidFill>
-            <a:srgbClr val="FFFFFF"/>
-          </a:solidFill>
-          <a:ln>
-            <a:noFill/>
-          </a:ln>
-          <a:effectLst/>
-        </p:spPr>
-        <p:style>
-          <a:lnRef idx="1">
-            <a:schemeClr val="accent1"/>
-          </a:lnRef>
-          <a:fillRef idx="3">
-            <a:schemeClr val="accent1"/>
-          </a:fillRef>
-          <a:effectRef idx="2">
-            <a:schemeClr val="accent1"/>
-          </a:effectRef>
-          <a:fontRef idx="minor">
-            <a:schemeClr val="lt1"/>
-          </a:fontRef>
-        </p:style>
-        <p:txBody>
-          <a:bodyPr rtlCol="0" anchor="ctr"/>
-          <a:lstStyle/>
-          <a:p>
-            <a:pPr algn="ctr"/>
-          </a:p>
-        </p:txBody>
-      </p:sp>
-      <p:sp>
-        <p:nvSpPr>
-          <p:cNvPr id="8" name="Rectangle 7"/>
-          <p:cNvSpPr/>
-          <p:nvPr/>
-        </p:nvSpPr>
-        <p:spPr>
-          <a:xfrm>
-            <a:off x="822960" y="1554480"/>
-            <a:ext cx="822960" cy="82296"/>
-          </a:xfrm>
-          <a:prstGeom prst="rect">
-            <a:avLst/>
-          </a:prstGeom>
-          <a:solidFill>
-            <a:srgbClr val="D52B1E"/>
-          </a:solidFill>
-          <a:ln>
-            <a:noFill/>
-          </a:ln>
-          <a:effectLst/>
-        </p:spPr>
-        <p:style>
-          <a:lnRef idx="1">
-            <a:schemeClr val="accent1"/>
-          </a:lnRef>
-          <a:fillRef idx="3">
-            <a:schemeClr val="accent1"/>
-          </a:fillRef>
-          <a:effectRef idx="2">
-            <a:schemeClr val="accent1"/>
-          </a:effectRef>
-          <a:fontRef idx="minor">
-            <a:schemeClr val="lt1"/>
-          </a:fontRef>
-        </p:style>
-        <p:txBody>
-          <a:bodyPr rtlCol="0" anchor="ctr"/>
-          <a:lstStyle/>
-          <a:p>
-            <a:pPr algn="ctr"/>
-          </a:p>
-        </p:txBody>
-      </p:sp>
-      <p:sp>
-        <p:nvSpPr>
-          <p:cNvPr id="9" name="TextBox 8"/>
+          <p:cNvPr id="3" name="TextBox 2"/>
           <p:cNvSpPr txBox="1"/>
           <p:nvPr/>
         </p:nvSpPr>
         <p:spPr>
           <a:xfrm>
-            <a:off x="777240" y="822960"/>
-            <a:ext cx="8229600" cy="457200"/>
+            <a:off x="777240" y="1828800"/>
+            <a:ext cx="10424160" cy="1828800"/>
           </a:xfrm>
           <a:prstGeom prst="rect">
             <a:avLst/>
@@ -3951,45 +3591,11 @@
           <a:lstStyle/>
           <a:p>
             <a:r>
-              <a:rPr sz="1300" b="1" i="0">
-                <a:solidFill>
-                  <a:srgbClr val="9FC3DC"/>
-                </a:solidFill>
-                <a:latin typeface="Calibri"/>
-              </a:rPr>
-              <a:t>BUZATU · MILLER FAMILY</a:t>
-            </a:r>
-          </a:p>
-        </p:txBody>
-      </p:sp>
-      <p:sp>
-        <p:nvSpPr>
-          <p:cNvPr id="10" name="TextBox 9"/>
-          <p:cNvSpPr txBox="1"/>
-          <p:nvPr/>
-        </p:nvSpPr>
-        <p:spPr>
-          <a:xfrm>
-            <a:off x="777240" y="1828800"/>
-            <a:ext cx="10424160" cy="1828800"/>
-          </a:xfrm>
-          <a:prstGeom prst="rect">
-            <a:avLst/>
-          </a:prstGeom>
-          <a:noFill/>
-        </p:spPr>
-        <p:txBody>
-          <a:bodyPr wrap="square" anchor="t" lIns="45720" rIns="45720" tIns="27432" bIns="27432">
-            <a:spAutoFit/>
-          </a:bodyPr>
-          <a:lstStyle/>
-          <a:p>
-            <a:r>
-              <a:rPr sz="4400" b="1" i="0">
+              <a:rPr sz="4400" b="0" i="0">
                 <a:solidFill>
                   <a:srgbClr val="FFFFFF"/>
                 </a:solidFill>
-                <a:latin typeface="Georgia"/>
+                <a:latin typeface="Calibri Light"/>
               </a:rPr>
               <a:t>The Swiss Cloud Debate</a:t>
             </a:r>
@@ -4003,45 +3609,11 @@
             <a:r>
               <a:rPr sz="2200" b="0" i="0">
                 <a:solidFill>
-                  <a:srgbClr val="CFE0EC"/>
+                  <a:srgbClr val="CFD6DD"/>
                 </a:solidFill>
                 <a:latin typeface="Calibri"/>
               </a:rPr>
               <a:t>A short briefing</a:t>
-            </a:r>
-          </a:p>
-        </p:txBody>
-      </p:sp>
-      <p:sp>
-        <p:nvSpPr>
-          <p:cNvPr id="11" name="TextBox 10"/>
-          <p:cNvSpPr txBox="1"/>
-          <p:nvPr/>
-        </p:nvSpPr>
-        <p:spPr>
-          <a:xfrm>
-            <a:off x="777240" y="3429000"/>
-            <a:ext cx="7315200" cy="365760"/>
-          </a:xfrm>
-          <a:prstGeom prst="rect">
-            <a:avLst/>
-          </a:prstGeom>
-          <a:noFill/>
-        </p:spPr>
-        <p:txBody>
-          <a:bodyPr wrap="square" anchor="t" lIns="45720" rIns="45720" tIns="27432" bIns="27432">
-            <a:spAutoFit/>
-          </a:bodyPr>
-          <a:lstStyle/>
-          <a:p>
-            <a:r>
-              <a:rPr sz="1400" b="0" i="0">
-                <a:solidFill>
-                  <a:srgbClr val="9FC3DC"/>
-                </a:solidFill>
-                <a:latin typeface="Calibri"/>
-              </a:rPr>
-              <a:t>Anne-Marie · 21 October 2026</a:t>
             </a:r>
           </a:p>
         </p:txBody>
@@ -4060,7 +3632,7 @@
     <p:bg>
       <p:bgPr>
         <a:solidFill>
-          <a:srgbClr val="2A6A98"/>
+          <a:srgbClr val="3E5C76"/>
         </a:solidFill>
         <a:effectLst/>
       </p:bgPr>
@@ -4139,11 +3711,11 @@
           <a:lstStyle/>
           <a:p>
             <a:r>
-              <a:rPr sz="4000" b="1" i="0">
+              <a:rPr sz="4000" b="0" i="0">
                 <a:solidFill>
                   <a:srgbClr val="FFFFFF"/>
                 </a:solidFill>
-                <a:latin typeface="Georgia"/>
+                <a:latin typeface="Calibri Light"/>
               </a:rPr>
               <a:t>Section One</a:t>
             </a:r>
@@ -4190,11 +3762,11 @@
           <a:p>
             <a:pPr algn="l"/>
             <a:r>
-              <a:rPr sz="3400" b="1" i="0">
+              <a:rPr sz="3400" b="0" i="0">
                 <a:solidFill>
-                  <a:srgbClr val="1F2A37"/>
+                  <a:srgbClr val="2B3E50"/>
                 </a:solidFill>
-                <a:latin typeface="Georgia"/>
+                <a:latin typeface="Calibri Light"/>
               </a:rPr>
               <a:t>Why it matters</a:t>
             </a:r>
@@ -4216,7 +3788,7 @@
             <a:avLst/>
           </a:prstGeom>
           <a:solidFill>
-            <a:srgbClr val="2A6A98"/>
+            <a:srgbClr val="3E5C76"/>
           </a:solidFill>
           <a:ln>
             <a:noFill/>
@@ -4260,7 +3832,7 @@
             <a:avLst/>
           </a:prstGeom>
           <a:solidFill>
-            <a:srgbClr val="D52B1E"/>
+            <a:srgbClr val="7C9CBA"/>
           </a:solidFill>
           <a:ln>
             <a:noFill/>
@@ -4304,7 +3876,7 @@
             <a:avLst/>
           </a:prstGeom>
           <a:solidFill>
-            <a:srgbClr val="C9D6E2"/>
+            <a:srgbClr val="CBD3DC"/>
           </a:solidFill>
           <a:ln>
             <a:noFill/>
@@ -4432,7 +4004,7 @@
                 <a:spcPts val="900"/>
               </a:spcAft>
               <a:buClr>
-                <a:srgbClr val="D52B1E"/>
+                <a:srgbClr val="7C9CBA"/>
               </a:buClr>
               <a:buFont typeface="Arial"/>
               <a:buChar char="•"/>
@@ -4456,7 +4028,7 @@
                 <a:spcPts val="900"/>
               </a:spcAft>
               <a:buClr>
-                <a:srgbClr val="2A6A98"/>
+                <a:srgbClr val="3E5C76"/>
               </a:buClr>
               <a:buFont typeface="Arial"/>
               <a:buChar char="–"/>
@@ -4480,7 +4052,7 @@
                 <a:spcPts val="900"/>
               </a:spcAft>
               <a:buClr>
-                <a:srgbClr val="D52B1E"/>
+                <a:srgbClr val="7C9CBA"/>
               </a:buClr>
               <a:buFont typeface="Arial"/>
               <a:buChar char="•"/>
@@ -4504,7 +4076,7 @@
                 <a:spcPts val="900"/>
               </a:spcAft>
               <a:buClr>
-                <a:srgbClr val="D52B1E"/>
+                <a:srgbClr val="7C9CBA"/>
               </a:buClr>
               <a:buFont typeface="Arial"/>
               <a:buChar char="•"/>
@@ -4561,11 +4133,11 @@
           <a:p>
             <a:pPr algn="l"/>
             <a:r>
-              <a:rPr sz="3400" b="1" i="0">
+              <a:rPr sz="3400" b="0" i="0">
                 <a:solidFill>
-                  <a:srgbClr val="1F2A37"/>
+                  <a:srgbClr val="2B3E50"/>
                 </a:solidFill>
-                <a:latin typeface="Georgia"/>
+                <a:latin typeface="Calibri Light"/>
               </a:rPr>
               <a:t>The big picture</a:t>
             </a:r>
@@ -4587,7 +4159,7 @@
             <a:avLst/>
           </a:prstGeom>
           <a:solidFill>
-            <a:srgbClr val="2A6A98"/>
+            <a:srgbClr val="3E5C76"/>
           </a:solidFill>
           <a:ln>
             <a:noFill/>
@@ -4631,7 +4203,7 @@
             <a:avLst/>
           </a:prstGeom>
           <a:solidFill>
-            <a:srgbClr val="D52B1E"/>
+            <a:srgbClr val="7C9CBA"/>
           </a:solidFill>
           <a:ln>
             <a:noFill/>
@@ -4675,7 +4247,7 @@
             <a:avLst/>
           </a:prstGeom>
           <a:solidFill>
-            <a:srgbClr val="C9D6E2"/>
+            <a:srgbClr val="CBD3DC"/>
           </a:solidFill>
           <a:ln>
             <a:noFill/>
@@ -4788,7 +4360,7 @@
             <a:avLst/>
           </a:prstGeom>
           <a:solidFill>
-            <a:srgbClr val="EAF1F7"/>
+            <a:srgbClr val="EDF1F5"/>
           </a:solidFill>
           <a:ln>
             <a:noFill/>
@@ -4832,7 +4404,7 @@
             <a:avLst/>
           </a:prstGeom>
           <a:solidFill>
-            <a:srgbClr val="D52B1E"/>
+            <a:srgbClr val="7C9CBA"/>
           </a:solidFill>
           <a:ln>
             <a:noFill/>
@@ -4886,9 +4458,9 @@
             <a:r>
               <a:rPr sz="3000" b="0" i="0">
                 <a:solidFill>
-                  <a:srgbClr val="1F2A37"/>
+                  <a:srgbClr val="2B3E50"/>
                 </a:solidFill>
-                <a:latin typeface="Georgia"/>
+                <a:latin typeface="Calibri Light"/>
               </a:rPr>
               <a:t>Sovereignty and cost pull in opposite directions.</a:t>
             </a:r>
@@ -4935,11 +4507,11 @@
           <a:p>
             <a:pPr algn="l"/>
             <a:r>
-              <a:rPr sz="3400" b="1" i="0">
+              <a:rPr sz="3400" b="0" i="0">
                 <a:solidFill>
-                  <a:srgbClr val="1F2A37"/>
+                  <a:srgbClr val="2B3E50"/>
                 </a:solidFill>
-                <a:latin typeface="Georgia"/>
+                <a:latin typeface="Calibri Light"/>
               </a:rPr>
               <a:t>Comparison</a:t>
             </a:r>
@@ -4961,7 +4533,7 @@
             <a:avLst/>
           </a:prstGeom>
           <a:solidFill>
-            <a:srgbClr val="2A6A98"/>
+            <a:srgbClr val="3E5C76"/>
           </a:solidFill>
           <a:ln>
             <a:noFill/>
@@ -5005,7 +4577,7 @@
             <a:avLst/>
           </a:prstGeom>
           <a:solidFill>
-            <a:srgbClr val="D52B1E"/>
+            <a:srgbClr val="7C9CBA"/>
           </a:solidFill>
           <a:ln>
             <a:noFill/>
@@ -5049,7 +4621,7 @@
             <a:avLst/>
           </a:prstGeom>
           <a:solidFill>
-            <a:srgbClr val="C9D6E2"/>
+            <a:srgbClr val="CBD3DC"/>
           </a:solidFill>
           <a:ln>
             <a:noFill/>
@@ -5190,7 +4762,7 @@
                   </a:txBody>
                   <a:tcPr marL="109728" marR="109728" anchor="ctr">
                     <a:solidFill>
-                      <a:srgbClr val="2A6A98"/>
+                      <a:srgbClr val="3E5C76"/>
                     </a:solidFill>
                   </a:tcPr>
                 </a:tc>
@@ -5213,7 +4785,7 @@
                   </a:txBody>
                   <a:tcPr marL="109728" marR="109728" anchor="ctr">
                     <a:solidFill>
-                      <a:srgbClr val="2A6A98"/>
+                      <a:srgbClr val="3E5C76"/>
                     </a:solidFill>
                   </a:tcPr>
                 </a:tc>
@@ -5236,7 +4808,7 @@
                   </a:txBody>
                   <a:tcPr marL="109728" marR="109728" anchor="ctr">
                     <a:solidFill>
-                      <a:srgbClr val="2A6A98"/>
+                      <a:srgbClr val="3E5C76"/>
                     </a:solidFill>
                   </a:tcPr>
                 </a:tc>
@@ -5332,7 +4904,7 @@
                   </a:txBody>
                   <a:tcPr marL="109728" marR="109728" anchor="ctr">
                     <a:solidFill>
-                      <a:srgbClr val="F4F8FB"/>
+                      <a:srgbClr val="F5F7FA"/>
                     </a:solidFill>
                   </a:tcPr>
                 </a:tc>
@@ -5355,7 +4927,7 @@
                   </a:txBody>
                   <a:tcPr marL="109728" marR="109728" anchor="ctr">
                     <a:solidFill>
-                      <a:srgbClr val="F4F8FB"/>
+                      <a:srgbClr val="F5F7FA"/>
                     </a:solidFill>
                   </a:tcPr>
                 </a:tc>
@@ -5378,7 +4950,7 @@
                   </a:txBody>
                   <a:tcPr marL="109728" marR="109728" anchor="ctr">
                     <a:solidFill>
-                      <a:srgbClr val="F4F8FB"/>
+                      <a:srgbClr val="F5F7FA"/>
                     </a:solidFill>
                   </a:tcPr>
                 </a:tc>
@@ -5427,11 +4999,11 @@
           <a:p>
             <a:pPr algn="l"/>
             <a:r>
-              <a:rPr sz="3400" b="1" i="0">
+              <a:rPr sz="3400" b="0" i="0">
                 <a:solidFill>
-                  <a:srgbClr val="1F2A37"/>
+                  <a:srgbClr val="2B3E50"/>
                 </a:solidFill>
-                <a:latin typeface="Georgia"/>
+                <a:latin typeface="Calibri Light"/>
               </a:rPr>
               <a:t>A long slide</a:t>
             </a:r>
@@ -5453,7 +5025,7 @@
             <a:avLst/>
           </a:prstGeom>
           <a:solidFill>
-            <a:srgbClr val="2A6A98"/>
+            <a:srgbClr val="3E5C76"/>
           </a:solidFill>
           <a:ln>
             <a:noFill/>
@@ -5497,7 +5069,7 @@
             <a:avLst/>
           </a:prstGeom>
           <a:solidFill>
-            <a:srgbClr val="D52B1E"/>
+            <a:srgbClr val="7C9CBA"/>
           </a:solidFill>
           <a:ln>
             <a:noFill/>
@@ -5541,7 +5113,7 @@
             <a:avLst/>
           </a:prstGeom>
           <a:solidFill>
-            <a:srgbClr val="C9D6E2"/>
+            <a:srgbClr val="CBD3DC"/>
           </a:solidFill>
           <a:ln>
             <a:noFill/>
@@ -5669,7 +5241,7 @@
                 <a:spcPts val="900"/>
               </a:spcAft>
               <a:buClr>
-                <a:srgbClr val="D52B1E"/>
+                <a:srgbClr val="7C9CBA"/>
               </a:buClr>
               <a:buFont typeface="Arial"/>
               <a:buChar char="•"/>
@@ -5693,7 +5265,7 @@
                 <a:spcPts val="900"/>
               </a:spcAft>
               <a:buClr>
-                <a:srgbClr val="D52B1E"/>
+                <a:srgbClr val="7C9CBA"/>
               </a:buClr>
               <a:buFont typeface="Arial"/>
               <a:buChar char="•"/>
@@ -5717,7 +5289,7 @@
                 <a:spcPts val="900"/>
               </a:spcAft>
               <a:buClr>
-                <a:srgbClr val="D52B1E"/>
+                <a:srgbClr val="7C9CBA"/>
               </a:buClr>
               <a:buFont typeface="Arial"/>
               <a:buChar char="•"/>
@@ -5774,11 +5346,11 @@
           <a:p>
             <a:pPr algn="l"/>
             <a:r>
-              <a:rPr sz="3400" b="1" i="0">
+              <a:rPr sz="3400" b="0" i="0">
                 <a:solidFill>
-                  <a:srgbClr val="1F2A37"/>
+                  <a:srgbClr val="2B3E50"/>
                 </a:solidFill>
-                <a:latin typeface="Georgia"/>
+                <a:latin typeface="Calibri Light"/>
               </a:rPr>
               <a:t>A long slide (cont.)</a:t>
             </a:r>
@@ -5800,7 +5372,7 @@
             <a:avLst/>
           </a:prstGeom>
           <a:solidFill>
-            <a:srgbClr val="2A6A98"/>
+            <a:srgbClr val="3E5C76"/>
           </a:solidFill>
           <a:ln>
             <a:noFill/>
@@ -5844,7 +5416,7 @@
             <a:avLst/>
           </a:prstGeom>
           <a:solidFill>
-            <a:srgbClr val="D52B1E"/>
+            <a:srgbClr val="7C9CBA"/>
           </a:solidFill>
           <a:ln>
             <a:noFill/>
@@ -5888,7 +5460,7 @@
             <a:avLst/>
           </a:prstGeom>
           <a:solidFill>
-            <a:srgbClr val="C9D6E2"/>
+            <a:srgbClr val="CBD3DC"/>
           </a:solidFill>
           <a:ln>
             <a:noFill/>
@@ -6016,7 +5588,7 @@
                 <a:spcPts val="900"/>
               </a:spcAft>
               <a:buClr>
-                <a:srgbClr val="D52B1E"/>
+                <a:srgbClr val="7C9CBA"/>
               </a:buClr>
               <a:buFont typeface="Arial"/>
               <a:buChar char="•"/>
@@ -6040,7 +5612,7 @@
                 <a:spcPts val="900"/>
               </a:spcAft>
               <a:buClr>
-                <a:srgbClr val="D52B1E"/>
+                <a:srgbClr val="7C9CBA"/>
               </a:buClr>
               <a:buFont typeface="Arial"/>
               <a:buChar char="•"/>
@@ -6064,7 +5636,7 @@
                 <a:spcPts val="900"/>
               </a:spcAft>
               <a:buClr>
-                <a:srgbClr val="D52B1E"/>
+                <a:srgbClr val="7C9CBA"/>
               </a:buClr>
               <a:buFont typeface="Arial"/>
               <a:buChar char="•"/>
@@ -6121,11 +5693,11 @@
           <a:p>
             <a:pPr algn="l"/>
             <a:r>
-              <a:rPr sz="3400" b="1" i="0">
+              <a:rPr sz="3400" b="0" i="0">
                 <a:solidFill>
-                  <a:srgbClr val="1F2A37"/>
+                  <a:srgbClr val="2B3E50"/>
                 </a:solidFill>
-                <a:latin typeface="Georgia"/>
+                <a:latin typeface="Calibri Light"/>
               </a:rPr>
               <a:t>A long slide (cont.)</a:t>
             </a:r>
@@ -6147,7 +5719,7 @@
             <a:avLst/>
           </a:prstGeom>
           <a:solidFill>
-            <a:srgbClr val="2A6A98"/>
+            <a:srgbClr val="3E5C76"/>
           </a:solidFill>
           <a:ln>
             <a:noFill/>
@@ -6191,7 +5763,7 @@
             <a:avLst/>
           </a:prstGeom>
           <a:solidFill>
-            <a:srgbClr val="D52B1E"/>
+            <a:srgbClr val="7C9CBA"/>
           </a:solidFill>
           <a:ln>
             <a:noFill/>
@@ -6235,7 +5807,7 @@
             <a:avLst/>
           </a:prstGeom>
           <a:solidFill>
-            <a:srgbClr val="C9D6E2"/>
+            <a:srgbClr val="CBD3DC"/>
           </a:solidFill>
           <a:ln>
             <a:noFill/>
@@ -6363,7 +5935,7 @@
                 <a:spcPts val="900"/>
               </a:spcAft>
               <a:buClr>
-                <a:srgbClr val="D52B1E"/>
+                <a:srgbClr val="7C9CBA"/>
               </a:buClr>
               <a:buFont typeface="Arial"/>
               <a:buChar char="•"/>
@@ -6387,7 +5959,7 @@
                 <a:spcPts val="900"/>
               </a:spcAft>
               <a:buClr>
-                <a:srgbClr val="D52B1E"/>
+                <a:srgbClr val="7C9CBA"/>
               </a:buClr>
               <a:buFont typeface="Arial"/>
               <a:buChar char="•"/>
@@ -6411,7 +5983,7 @@
                 <a:spcPts val="900"/>
               </a:spcAft>
               <a:buClr>
-                <a:srgbClr val="D52B1E"/>
+                <a:srgbClr val="7C9CBA"/>
               </a:buClr>
               <a:buFont typeface="Arial"/>
               <a:buChar char="•"/>
@@ -6468,11 +6040,11 @@
           <a:p>
             <a:pPr algn="l"/>
             <a:r>
-              <a:rPr sz="3400" b="1" i="0">
+              <a:rPr sz="3400" b="0" i="0">
                 <a:solidFill>
-                  <a:srgbClr val="1F2A37"/>
+                  <a:srgbClr val="2B3E50"/>
                 </a:solidFill>
-                <a:latin typeface="Georgia"/>
+                <a:latin typeface="Calibri Light"/>
               </a:rPr>
               <a:t>A long slide (cont.)</a:t>
             </a:r>
@@ -6494,7 +6066,7 @@
             <a:avLst/>
           </a:prstGeom>
           <a:solidFill>
-            <a:srgbClr val="2A6A98"/>
+            <a:srgbClr val="3E5C76"/>
           </a:solidFill>
           <a:ln>
             <a:noFill/>
@@ -6538,7 +6110,7 @@
             <a:avLst/>
           </a:prstGeom>
           <a:solidFill>
-            <a:srgbClr val="D52B1E"/>
+            <a:srgbClr val="7C9CBA"/>
           </a:solidFill>
           <a:ln>
             <a:noFill/>
@@ -6582,7 +6154,7 @@
             <a:avLst/>
           </a:prstGeom>
           <a:solidFill>
-            <a:srgbClr val="C9D6E2"/>
+            <a:srgbClr val="CBD3DC"/>
           </a:solidFill>
           <a:ln>
             <a:noFill/>
@@ -6710,7 +6282,7 @@
                 <a:spcPts val="900"/>
               </a:spcAft>
               <a:buClr>
-                <a:srgbClr val="D52B1E"/>
+                <a:srgbClr val="7C9CBA"/>
               </a:buClr>
               <a:buFont typeface="Arial"/>
               <a:buChar char="•"/>
@@ -6734,7 +6306,7 @@
                 <a:spcPts val="900"/>
               </a:spcAft>
               <a:buClr>
-                <a:srgbClr val="D52B1E"/>
+                <a:srgbClr val="7C9CBA"/>
               </a:buClr>
               <a:buFont typeface="Arial"/>
               <a:buChar char="•"/>

</xml_diff>